<commit_message>
Remove all em dashes from PD2 deck slides and speaker notes
Rewrites each em-dash construction with the punctuation that actually
fits (colon, comma, semicolon, or parentheses) rather than deleting
the character outright, and swaps standalone bullet-marker em dashes
for a bullet glyph.

Co-Authored-By: Claude Sonnet 5 <noreply@anthropic.com>
Claude-Session: https://claude.ai/code/session_01323g8wH7t7kJoxkJfyNLN3
</commit_message>
<xml_diff>
--- a/matlab/audio-analysis/PD2_SectionM1_Group1.pptx
+++ b/matlab/audio-analysis/PD2_SectionM1_Group1.pptx
@@ -513,7 +513,7 @@
           <a:p>
             <a:r>
               <a:rPr lang="en-US" dirty="0"/>
-              <a:t>Good morning. We are Group 1, Section M1. This is our PD2 presentation: analysis of Code1 applied to AudioA — how the code works, the results it produces, and why the filter stage behaves the way it does.</a:t>
+              <a:t>Good morning. We are Group 1, Section M1. This is our PD2 presentation: analysis of Code1 applied to AudioA, covering how the code works, the results it produces, and why the filter stage behaves the way it does.</a:t>
             </a:r>
             <a:endParaRPr lang="en-US" dirty="0"/>
           </a:p>
@@ -601,7 +601,7 @@
           <a:p>
             <a:r>
               <a:rPr lang="en-US" dirty="0"/>
-              <a:t>Ahmed: Three practical fixes. First, use second-order sections — butter with the 'sos' output stays numerically stable at any order. Second, reduce the order: a 2nd or 3rd order filter at the same cutoff is stable even in TF form. Third, question the cutoff itself: if the goal is to keep speech, the cutoff should sit near the top of the speech band, e.g. 3–4 kHz, not 160 Hz. Good filter choice means matching type, order, cutoff AND implementation form to the task.</a:t>
+              <a:t>Ahmed: Three practical fixes. First, use second-order sections: butter with the 'sos' output stays numerically stable at any order. Second, reduce the order: a 2nd or 3rd order filter at the same cutoff is stable even in TF form. Third, question the cutoff itself: if the goal is to keep speech, the cutoff should sit near the top of the speech band, e.g. 3–4 kHz, not 160 Hz. Good filter choice means matching type, order, cutoff AND implementation form to the task.</a:t>
             </a:r>
             <a:endParaRPr lang="en-US" dirty="0"/>
           </a:p>
@@ -689,7 +689,7 @@
           <a:p>
             <a:r>
               <a:rPr lang="en-US" dirty="0"/>
-              <a:t>All: Each member takes one card. Keep it specific — what this part of the project actually taught us.</a:t>
+              <a:t>All: Each member takes one card. Keep it specific: what this part of the project actually taught us.</a:t>
             </a:r>
             <a:endParaRPr lang="en-US" dirty="0"/>
           </a:p>
@@ -777,7 +777,7 @@
           <a:p>
             <a:r>
               <a:rPr lang="en-US" dirty="0"/>
-              <a:t>All: Recap — the code's analysis stages work correctly and confirm the sampling theorem; the filter stage fails because a 9th-order Butterworth at a 0.0067π cutoff is numerically unstable in transfer-function form; the fix is SOS form, lower order, or a sensible cutoff. Future work: apply the corrected filter and compare audio quality. Thank the audience.</a:t>
+              <a:t>All: Recap: the code's analysis stages work correctly and confirm the sampling theorem; the filter stage fails because a 9th-order Butterworth at a 0.0067π cutoff is numerically unstable in transfer-function form; the fix is SOS form, lower order, or a sensible cutoff. Future work: apply the corrected filter and compare audio quality. Thank the audience.</a:t>
             </a:r>
             <a:endParaRPr lang="en-US" dirty="0"/>
           </a:p>
@@ -865,7 +865,7 @@
           <a:p>
             <a:r>
               <a:rPr lang="en-US" dirty="0"/>
-              <a:t>Abdulrahman: PD2 covers Part 2 of the project — we were given Code1 and AudioA. Objectives: understand what each block of the code does, run it on the audio file, present the plots, and explain why the results look the way they do — especially the filter stage.</a:t>
+              <a:t>Abdulrahman: PD2 covers Part 2 of the project. We were given Code1 and AudioA. Objectives: understand what each block of the code does, run it on the audio file, present the plots, and explain why the results look the way they do, especially the filter stage.</a:t>
             </a:r>
             <a:endParaRPr lang="en-US" dirty="0"/>
           </a:p>
@@ -1129,7 +1129,7 @@
           <a:p>
             <a:r>
               <a:rPr lang="en-US" dirty="0"/>
-              <a:t>Nasser: The recording is about 1.6 seconds of speech — five distinct bursts, each burst a word or syllable, separated by near-silence. Amplitude is normalized within ±1. This is what we expect from a clean speech recording.</a:t>
+              <a:t>Nasser: The recording is about 1.6 seconds of speech: five distinct bursts, each burst a word or syllable, separated by near-silence. Amplitude is normalized within ±1. This is what we expect from a clean speech recording.</a:t>
             </a:r>
             <a:endParaRPr lang="en-US" dirty="0"/>
           </a:p>
@@ -1217,7 +1217,7 @@
           <a:p>
             <a:r>
               <a:rPr lang="en-US" dirty="0"/>
-              <a:t>Nasser: The two-sided spectrum from fftshift is symmetric around 0 Hz, as it must be for a real signal. Energy is concentrated below about 8 kHz — typical for speech. The axis extends to ±24 kHz, which is Fs/2: the Nyquist frequency. Since the content stops well below 24 kHz, sampling at 48 kHz satisfies the sampling theorem with a wide margin.</a:t>
+              <a:t>Nasser: The two-sided spectrum from fftshift is symmetric around 0 Hz, as it must be for a real signal. Energy is concentrated below about 8 kHz, typical for speech. The axis extends to ±24 kHz, which is Fs/2: the Nyquist frequency. Since the content stops well below 24 kHz, sampling at 48 kHz satisfies the sampling theorem with a wide margin.</a:t>
             </a:r>
             <a:endParaRPr lang="en-US" dirty="0"/>
           </a:p>
@@ -1305,7 +1305,7 @@
           <a:p>
             <a:r>
               <a:rPr lang="en-US" dirty="0"/>
-              <a:t>Nasser: freqz shows the designed filter's response — and it is the first warning sign. A healthy low-pass filter shows a flat 0 dB passband, then a roll-off. Here there is no flat passband at all: magnitude starts falling immediately and drops hundreds of dB. The phase plot is equally distorted. The filter as designed does not look like a usable low-pass filter — Ahmed will explain why.</a:t>
+              <a:t>Nasser: freqz shows the designed filter's response, and it is the first warning sign. A healthy low-pass filter shows a flat 0 dB passband, then a roll-off. Here there is no flat passband at all: magnitude starts falling immediately and drops hundreds of dB. The phase plot is equally distorted. The filter as designed does not look like a usable low-pass filter; Ahmed will explain why.</a:t>
             </a:r>
             <a:endParaRPr lang="en-US" dirty="0"/>
           </a:p>
@@ -1393,7 +1393,7 @@
           <a:p>
             <a:r>
               <a:rPr lang="en-US" dirty="0"/>
-              <a:t>Ahmed: After applying the filter, the spectrum shows amplitudes around 10 to the power 287 — astronomically large, close to the largest number a computer can represent. A filter can only attenuate or slightly amplify; it can never multiply a signal by 10^287. This is not a signal anymore — it is numerical divergence. The filter is unstable in implementation.</a:t>
+              <a:t>Ahmed: After applying the filter, the spectrum shows amplitudes around 10 to the power 287, astronomically large, close to the largest number a computer can represent. A filter can only attenuate or slightly amplify; it can never multiply a signal by 10^287. This is not a signal anymore; it is numerical divergence. The filter is unstable in implementation.</a:t>
             </a:r>
             <a:endParaRPr lang="en-US" dirty="0"/>
           </a:p>
@@ -1481,7 +1481,7 @@
           <a:p>
             <a:r>
               <a:rPr lang="en-US" dirty="0"/>
-              <a:t>Ahmed: The root cause is one line. The normalized cutoff is 0.02 times 8000 over 24000 — about 0.0067, i.e. 160 Hz out of a 24 kHz range. A 9th-order Butterworth at such an extremely narrow cutoff places all nine poles crowded just inside z = 1. In transfer-function form the polynomial coefficients become so ill-conditioned that rounding errors push poles outside the unit circle — the recursion diverges. This is a known numerical limitation, not an Octave or MATLAB bug.</a:t>
+              <a:t>Ahmed: The root cause is one line. The normalized cutoff is 0.02 times 8000 over 24000, about 0.0067, i.e. 160 Hz out of a 24 kHz range. A 9th-order Butterworth at such an extremely narrow cutoff places all nine poles crowded just inside z = 1. In transfer-function form the polynomial coefficients become so ill-conditioned that rounding errors push poles outside the unit circle, and the recursion diverges. This is a known numerical limitation, not an Octave or MATLAB bug.</a:t>
             </a:r>
             <a:endParaRPr lang="en-US" dirty="0"/>
           </a:p>
@@ -1953,7 +1953,7 @@
                 <a:ea typeface="Georgia" pitchFamily="34" charset="-122"/>
                 <a:cs typeface="Georgia" pitchFamily="34" charset="-120"/>
               </a:rPr>
-              <a:t>PD2 — Audio Signal Processing: Code Analysis &amp; Results</a:t>
+              <a:t>PD2: Audio Signal Processing, Code Analysis &amp; Results</a:t>
             </a:r>
             <a:endParaRPr lang="en-US" sz="6900" dirty="0"/>
           </a:p>
@@ -2441,7 +2441,7 @@
                 <a:ea typeface="Arial" pitchFamily="34" charset="-122"/>
                 <a:cs typeface="Arial" pitchFamily="34" charset="-120"/>
               </a:rPr>
-              <a:t>SOS form factors the filter into stable 2nd-order stages — immune to the coefficient ill-conditioning that broke the TF form.</a:t>
+              <a:t>SOS form factors the filter into stable 2nd-order stages, immune to the coefficient ill-conditioning that broke the TF form.</a:t>
             </a:r>
             <a:endParaRPr lang="en-US" sz="2100" dirty="0"/>
           </a:p>
@@ -2607,7 +2607,7 @@
                 <a:ea typeface="Arial" pitchFamily="34" charset="-122"/>
                 <a:cs typeface="Arial" pitchFamily="34" charset="-120"/>
               </a:rPr>
-              <a:t>At order 2–3 the same cutoff is numerically safe even in transfer-function form — at the cost of a gentler roll-off.</a:t>
+              <a:t>At order 2–3 the same cutoff is numerically safe even in transfer-function form, at the cost of a gentler roll-off.</a:t>
             </a:r>
             <a:endParaRPr lang="en-US" sz="2100" dirty="0"/>
           </a:p>
@@ -3140,7 +3140,7 @@
                 <a:ea typeface="Arial" pitchFamily="34" charset="-122"/>
                 <a:cs typeface="Arial" pitchFamily="34" charset="-120"/>
               </a:rPr>
-              <a:t>Our first instinct was that we ran the code wrong. Reading the plots carefully — a 10²⁸⁷ amplitude — proved the code itself was the story.</a:t>
+              <a:t>Our first instinct was that we ran the code wrong. Reading the plots carefully (a 10²⁸⁷ amplitude) proved the code itself was the story.</a:t>
             </a:r>
             <a:endParaRPr lang="en-US" sz="2175" dirty="0"/>
           </a:p>
@@ -3250,7 +3250,7 @@
                 <a:ea typeface="Arial" pitchFamily="34" charset="-122"/>
                 <a:cs typeface="Arial" pitchFamily="34" charset="-120"/>
               </a:rPr>
-              <a:t>One member traced the code line by line, one researched Butterworth stability, one reproduced the fix — dividing the investigation made the diagnosis fast.</a:t>
+              <a:t>One member traced the code line by line, one researched Butterworth stability, and one reproduced the fix: dividing the investigation made the diagnosis fast.</a:t>
             </a:r>
             <a:endParaRPr lang="en-US" sz="2175" dirty="0"/>
           </a:p>
@@ -4456,7 +4456,7 @@
                 <a:ea typeface="Arial" pitchFamily="34" charset="-122"/>
                 <a:cs typeface="Arial" pitchFamily="34" charset="-120"/>
               </a:rPr>
-              <a:t>Interpret each plot and investigate whether the given filter is a good choice — and why the output shows it is not.</a:t>
+              <a:t>Interpret each plot and investigate whether the given filter is a good choice, and why the output shows it is not.</a:t>
             </a:r>
             <a:endParaRPr lang="en-US" sz="2250" dirty="0"/>
           </a:p>
@@ -4517,7 +4517,7 @@
                 <a:ea typeface="Arial" pitchFamily="34" charset="-122"/>
                 <a:cs typeface="Arial" pitchFamily="34" charset="-120"/>
               </a:rPr>
-              <a:t>The key learning goal: a filter can be mathematically defined yet fail in practice — good filter choice matters.</a:t>
+              <a:t>The key learning goal: a filter can be mathematically defined yet fail in practice, so good filter choice matters.</a:t>
             </a:r>
             <a:endParaRPr lang="en-US" sz="2250" dirty="0"/>
           </a:p>
@@ -4754,7 +4754,7 @@
                 <a:ea typeface="Arial" pitchFamily="34" charset="-122"/>
                 <a:cs typeface="Arial" pitchFamily="34" charset="-120"/>
               </a:rPr>
-              <a:t>Criteria — what success looks like</a:t>
+              <a:t>Criteria: what success looks like</a:t>
             </a:r>
             <a:endParaRPr lang="en-US" sz="2550" dirty="0"/>
           </a:p>
@@ -4798,7 +4798,7 @@
                 <a:ea typeface="Arial" pitchFamily="34" charset="-122"/>
                 <a:cs typeface="Arial" pitchFamily="34" charset="-120"/>
               </a:rPr>
-              <a:t>—</a:t>
+              <a:t>•</a:t>
             </a:r>
             <a:endParaRPr lang="en-US" sz="2250" dirty="0"/>
           </a:p>
@@ -4886,7 +4886,7 @@
                 <a:ea typeface="Arial" pitchFamily="34" charset="-122"/>
                 <a:cs typeface="Arial" pitchFamily="34" charset="-120"/>
               </a:rPr>
-              <a:t>—</a:t>
+              <a:t>•</a:t>
             </a:r>
             <a:endParaRPr lang="en-US" sz="2250" dirty="0"/>
           </a:p>
@@ -4974,7 +4974,7 @@
                 <a:ea typeface="Arial" pitchFamily="34" charset="-122"/>
                 <a:cs typeface="Arial" pitchFamily="34" charset="-120"/>
               </a:rPr>
-              <a:t>—</a:t>
+              <a:t>•</a:t>
             </a:r>
             <a:endParaRPr lang="en-US" sz="2250" dirty="0"/>
           </a:p>
@@ -5062,7 +5062,7 @@
                 <a:ea typeface="Arial" pitchFamily="34" charset="-122"/>
                 <a:cs typeface="Arial" pitchFamily="34" charset="-120"/>
               </a:rPr>
-              <a:t>—</a:t>
+              <a:t>•</a:t>
             </a:r>
             <a:endParaRPr lang="en-US" sz="2250" dirty="0"/>
           </a:p>
@@ -5147,7 +5147,7 @@
                 <a:ea typeface="Arial" pitchFamily="34" charset="-122"/>
                 <a:cs typeface="Arial" pitchFamily="34" charset="-120"/>
               </a:rPr>
-              <a:t>Constraints — what we must work within</a:t>
+              <a:t>Constraints: what we must work within</a:t>
             </a:r>
             <a:endParaRPr lang="en-US" sz="2550" dirty="0"/>
           </a:p>
@@ -5191,7 +5191,7 @@
                 <a:ea typeface="Arial" pitchFamily="34" charset="-122"/>
                 <a:cs typeface="Arial" pitchFamily="34" charset="-120"/>
               </a:rPr>
-              <a:t>—</a:t>
+              <a:t>•</a:t>
             </a:r>
             <a:endParaRPr lang="en-US" sz="2250" dirty="0"/>
           </a:p>
@@ -5235,7 +5235,7 @@
                 <a:ea typeface="Arial" pitchFamily="34" charset="-122"/>
                 <a:cs typeface="Arial" pitchFamily="34" charset="-120"/>
               </a:rPr>
-              <a:t>Assigned code: Code1 — run as given, unmodified</a:t>
+              <a:t>Assigned code: Code1, run as given and unmodified</a:t>
             </a:r>
             <a:endParaRPr lang="en-US" sz="2250" dirty="0"/>
           </a:p>
@@ -5279,7 +5279,7 @@
                 <a:ea typeface="Arial" pitchFamily="34" charset="-122"/>
                 <a:cs typeface="Arial" pitchFamily="34" charset="-120"/>
               </a:rPr>
-              <a:t>—</a:t>
+              <a:t>•</a:t>
             </a:r>
             <a:endParaRPr lang="en-US" sz="2250" dirty="0"/>
           </a:p>
@@ -5367,7 +5367,7 @@
                 <a:ea typeface="Arial" pitchFamily="34" charset="-122"/>
                 <a:cs typeface="Arial" pitchFamily="34" charset="-120"/>
               </a:rPr>
-              <a:t>—</a:t>
+              <a:t>•</a:t>
             </a:r>
             <a:endParaRPr lang="en-US" sz="2250" dirty="0"/>
           </a:p>
@@ -5455,7 +5455,7 @@
                 <a:ea typeface="Arial" pitchFamily="34" charset="-122"/>
                 <a:cs typeface="Arial" pitchFamily="34" charset="-120"/>
               </a:rPr>
-              <a:t>—</a:t>
+              <a:t>•</a:t>
             </a:r>
             <a:endParaRPr lang="en-US" sz="2250" dirty="0"/>
           </a:p>
@@ -6109,7 +6109,7 @@
                 <a:ea typeface="Arial" pitchFamily="34" charset="-122"/>
                 <a:cs typeface="Arial" pitchFamily="34" charset="-120"/>
               </a:rPr>
-              <a:t>Read AudioA — audioread, Fs = 48 kHz</a:t>
+              <a:t>Read AudioA: audioread, Fs = 48 kHz</a:t>
             </a:r>
             <a:endParaRPr lang="en-US" sz="2151" dirty="0"/>
           </a:p>
@@ -6474,7 +6474,7 @@
                 <a:ea typeface="Arial" pitchFamily="34" charset="-122"/>
                 <a:cs typeface="Arial" pitchFamily="34" charset="-120"/>
               </a:rPr>
-              <a:t>Design LPF — butter(9, 0.02·fmax/(Fs/2))</a:t>
+              <a:t>Design LPF: butter(9, 0.02·fmax/(Fs/2))</a:t>
             </a:r>
             <a:endParaRPr lang="en-US" sz="2025" dirty="0"/>
           </a:p>
@@ -6560,7 +6560,7 @@
                 <a:ea typeface="Arial" pitchFamily="34" charset="-122"/>
                 <a:cs typeface="Arial" pitchFamily="34" charset="-120"/>
               </a:rPr>
-              <a:t>Inspect response — freqz(b, a)</a:t>
+              <a:t>Inspect response: freqz(b, a)</a:t>
             </a:r>
             <a:endParaRPr lang="en-US" sz="2025" dirty="0"/>
           </a:p>
@@ -6773,7 +6773,7 @@
                 <a:ea typeface="Arial" pitchFamily="34" charset="-122"/>
                 <a:cs typeface="Arial" pitchFamily="34" charset="-120"/>
               </a:rPr>
-              <a:t>No — investigated on slides 8–10</a:t>
+              <a:t>No: investigated on slides 8–10</a:t>
             </a:r>
             <a:endParaRPr lang="en-US" sz="1950" dirty="0"/>
           </a:p>
@@ -7055,7 +7055,7 @@
                 <a:ea typeface="Arial" pitchFamily="34" charset="-122"/>
                 <a:cs typeface="Arial" pitchFamily="34" charset="-120"/>
               </a:rPr>
-              <a:t>AudioA waveform — amplitude vs time</a:t>
+              <a:t>AudioA waveform: amplitude vs time</a:t>
             </a:r>
             <a:endParaRPr lang="en-US" sz="1950" dirty="0"/>
           </a:p>
@@ -7099,7 +7099,7 @@
                 <a:ea typeface="Arial" pitchFamily="34" charset="-122"/>
                 <a:cs typeface="Arial" pitchFamily="34" charset="-120"/>
               </a:rPr>
-              <a:t>—</a:t>
+              <a:t>•</a:t>
             </a:r>
             <a:endParaRPr lang="en-US" sz="2250" dirty="0"/>
           </a:p>
@@ -7187,7 +7187,7 @@
                 <a:ea typeface="Arial" pitchFamily="34" charset="-122"/>
                 <a:cs typeface="Arial" pitchFamily="34" charset="-120"/>
               </a:rPr>
-              <a:t>—</a:t>
+              <a:t>•</a:t>
             </a:r>
             <a:endParaRPr lang="en-US" sz="2250" dirty="0"/>
           </a:p>
@@ -7275,7 +7275,7 @@
                 <a:ea typeface="Arial" pitchFamily="34" charset="-122"/>
                 <a:cs typeface="Arial" pitchFamily="34" charset="-120"/>
               </a:rPr>
-              <a:t>—</a:t>
+              <a:t>•</a:t>
             </a:r>
             <a:endParaRPr lang="en-US" sz="2250" dirty="0"/>
           </a:p>
@@ -7363,7 +7363,7 @@
                 <a:ea typeface="Arial" pitchFamily="34" charset="-122"/>
                 <a:cs typeface="Arial" pitchFamily="34" charset="-120"/>
               </a:rPr>
-              <a:t>—</a:t>
+              <a:t>•</a:t>
             </a:r>
             <a:endParaRPr lang="en-US" sz="2250" dirty="0"/>
           </a:p>
@@ -7407,7 +7407,7 @@
                 <a:ea typeface="Arial" pitchFamily="34" charset="-122"/>
                 <a:cs typeface="Arial" pitchFamily="34" charset="-120"/>
               </a:rPr>
-              <a:t>Sampled at Fs = 48 kHz — 48,000 samples per second</a:t>
+              <a:t>Sampled at Fs = 48 kHz, i.e. 48,000 samples per second</a:t>
             </a:r>
             <a:endParaRPr lang="en-US" sz="2250" dirty="0"/>
           </a:p>
@@ -7733,7 +7733,7 @@
                 <a:ea typeface="Arial" pitchFamily="34" charset="-122"/>
                 <a:cs typeface="Arial" pitchFamily="34" charset="-120"/>
               </a:rPr>
-              <a:t>—</a:t>
+              <a:t>•</a:t>
             </a:r>
             <a:endParaRPr lang="en-US" sz="2250" dirty="0"/>
           </a:p>
@@ -7777,7 +7777,7 @@
                 <a:ea typeface="Arial" pitchFamily="34" charset="-122"/>
                 <a:cs typeface="Arial" pitchFamily="34" charset="-120"/>
               </a:rPr>
-              <a:t>Symmetric about 0 Hz — the signature of a real-valued signal</a:t>
+              <a:t>Symmetric about 0 Hz: the signature of a real-valued signal</a:t>
             </a:r>
             <a:endParaRPr lang="en-US" sz="2250" dirty="0"/>
           </a:p>
@@ -7821,7 +7821,7 @@
                 <a:ea typeface="Arial" pitchFamily="34" charset="-122"/>
                 <a:cs typeface="Arial" pitchFamily="34" charset="-120"/>
               </a:rPr>
-              <a:t>—</a:t>
+              <a:t>•</a:t>
             </a:r>
             <a:endParaRPr lang="en-US" sz="2250" dirty="0"/>
           </a:p>
@@ -7865,7 +7865,7 @@
                 <a:ea typeface="Arial" pitchFamily="34" charset="-122"/>
                 <a:cs typeface="Arial" pitchFamily="34" charset="-120"/>
               </a:rPr>
-              <a:t>Energy concentrated below ≈ 8 kHz — the speech band</a:t>
+              <a:t>Energy concentrated below ≈ 8 kHz: the speech band</a:t>
             </a:r>
             <a:endParaRPr lang="en-US" sz="2250" dirty="0"/>
           </a:p>
@@ -7909,7 +7909,7 @@
                 <a:ea typeface="Arial" pitchFamily="34" charset="-122"/>
                 <a:cs typeface="Arial" pitchFamily="34" charset="-120"/>
               </a:rPr>
-              <a:t>—</a:t>
+              <a:t>•</a:t>
             </a:r>
             <a:endParaRPr lang="en-US" sz="2250" dirty="0"/>
           </a:p>
@@ -7997,7 +7997,7 @@
                 <a:ea typeface="Arial" pitchFamily="34" charset="-122"/>
                 <a:cs typeface="Arial" pitchFamily="34" charset="-120"/>
               </a:rPr>
-              <a:t>—</a:t>
+              <a:t>•</a:t>
             </a:r>
             <a:endParaRPr lang="en-US" sz="2250" dirty="0"/>
           </a:p>
@@ -8041,7 +8041,7 @@
                 <a:ea typeface="Arial" pitchFamily="34" charset="-122"/>
                 <a:cs typeface="Arial" pitchFamily="34" charset="-120"/>
               </a:rPr>
-              <a:t>Fs = 48 kHz &gt; 2·fmax — the sampling theorem is satisfied with ample margin</a:t>
+              <a:t>Fs = 48 kHz &gt; 2·fmax, so the sampling theorem is satisfied with ample margin</a:t>
             </a:r>
             <a:endParaRPr lang="en-US" sz="2250" dirty="0"/>
           </a:p>
@@ -8367,7 +8367,7 @@
                 <a:ea typeface="Arial" pitchFamily="34" charset="-122"/>
                 <a:cs typeface="Arial" pitchFamily="34" charset="-120"/>
               </a:rPr>
-              <a:t>—</a:t>
+              <a:t>•</a:t>
             </a:r>
             <a:endParaRPr lang="en-US" sz="2250" dirty="0"/>
           </a:p>
@@ -8455,7 +8455,7 @@
                 <a:ea typeface="Arial" pitchFamily="34" charset="-122"/>
                 <a:cs typeface="Arial" pitchFamily="34" charset="-120"/>
               </a:rPr>
-              <a:t>—</a:t>
+              <a:t>•</a:t>
             </a:r>
             <a:endParaRPr lang="en-US" sz="2250" dirty="0"/>
           </a:p>
@@ -8499,7 +8499,7 @@
                 <a:ea typeface="Arial" pitchFamily="34" charset="-122"/>
                 <a:cs typeface="Arial" pitchFamily="34" charset="-120"/>
               </a:rPr>
-              <a:t>Observed: no passband at all — magnitude falls immediately, reaching −400 dB and below</a:t>
+              <a:t>Observed: no passband at all; magnitude falls immediately, reaching −400 dB and below</a:t>
             </a:r>
             <a:endParaRPr lang="en-US" sz="2250" dirty="0"/>
           </a:p>
@@ -8543,7 +8543,7 @@
                 <a:ea typeface="Arial" pitchFamily="34" charset="-122"/>
                 <a:cs typeface="Arial" pitchFamily="34" charset="-120"/>
               </a:rPr>
-              <a:t>—</a:t>
+              <a:t>•</a:t>
             </a:r>
             <a:endParaRPr lang="en-US" sz="2250" dirty="0"/>
           </a:p>
@@ -8933,7 +8933,7 @@
                 <a:ea typeface="Arial" pitchFamily="34" charset="-122"/>
                 <a:cs typeface="Arial" pitchFamily="34" charset="-120"/>
               </a:rPr>
-              <a:t>Spectrum of the filtered signal — amplitude scale reaches 1.2×10²⁸⁷</a:t>
+              <a:t>Spectrum of the filtered signal: amplitude scale reaches 1.2×10²⁸⁷</a:t>
             </a:r>
             <a:endParaRPr lang="en-US" sz="1950" dirty="0"/>
           </a:p>
@@ -8977,7 +8977,7 @@
                 <a:ea typeface="Arial" pitchFamily="34" charset="-122"/>
                 <a:cs typeface="Arial" pitchFamily="34" charset="-120"/>
               </a:rPr>
-              <a:t>—</a:t>
+              <a:t>•</a:t>
             </a:r>
             <a:endParaRPr lang="en-US" sz="2250" dirty="0"/>
           </a:p>
@@ -9065,7 +9065,7 @@
                 <a:ea typeface="Arial" pitchFamily="34" charset="-122"/>
                 <a:cs typeface="Arial" pitchFamily="34" charset="-120"/>
               </a:rPr>
-              <a:t>—</a:t>
+              <a:t>•</a:t>
             </a:r>
             <a:endParaRPr lang="en-US" sz="2250" dirty="0"/>
           </a:p>
@@ -9109,7 +9109,7 @@
                 <a:ea typeface="Arial" pitchFamily="34" charset="-122"/>
                 <a:cs typeface="Arial" pitchFamily="34" charset="-120"/>
               </a:rPr>
-              <a:t>A filter can attenuate or amplify slightly — it cannot produce a gain of 10²⁸⁷</a:t>
+              <a:t>A filter can attenuate or amplify slightly; it cannot produce a gain of 10²⁸⁷</a:t>
             </a:r>
             <a:endParaRPr lang="en-US" sz="2250" dirty="0"/>
           </a:p>
@@ -9153,7 +9153,7 @@
                 <a:ea typeface="Arial" pitchFamily="34" charset="-122"/>
                 <a:cs typeface="Arial" pitchFamily="34" charset="-120"/>
               </a:rPr>
-              <a:t>—</a:t>
+              <a:t>•</a:t>
             </a:r>
             <a:endParaRPr lang="en-US" sz="2250" dirty="0"/>
           </a:p>
@@ -9261,7 +9261,7 @@
                 <a:ea typeface="Arial" pitchFamily="34" charset="-122"/>
                 <a:cs typeface="Arial" pitchFamily="34" charset="-120"/>
               </a:rPr>
-              <a:t>The filter is numerically unstable — the output is meaningless.</a:t>
+              <a:t>The filter is numerically unstable: the output is meaningless.</a:t>
             </a:r>
             <a:endParaRPr lang="en-US" sz="2325" dirty="0"/>
           </a:p>
@@ -9702,7 +9702,7 @@
                 <a:ea typeface="Arial" pitchFamily="34" charset="-122"/>
                 <a:cs typeface="Arial" pitchFamily="34" charset="-120"/>
               </a:rPr>
-              <a:t>— only 160 Hz out of a 24 kHz range. That removes nearly all speech content by design.</a:t>
+              <a:t>: only 160 Hz out of a 24 kHz range. That removes nearly all speech content by design.</a:t>
             </a:r>
             <a:endParaRPr lang="en-US" sz="2100" dirty="0"/>
           </a:p>
@@ -9812,7 +9812,7 @@
                 <a:ea typeface="Arial" pitchFamily="34" charset="-122"/>
                 <a:cs typeface="Arial" pitchFamily="34" charset="-120"/>
               </a:rPr>
-              <a:t>A 9th-order design at that cutoff crowds all nine poles just inside z = 1. The transfer-function coefficients become ill-conditioned — rounding errors push poles outside the unit circle.</a:t>
+              <a:t>A 9th-order design at that cutoff crowds all nine poles just inside z = 1. The transfer-function coefficients become ill-conditioned, so rounding errors push poles outside the unit circle.</a:t>
             </a:r>
             <a:endParaRPr lang="en-US" sz="2100" dirty="0"/>
           </a:p>
@@ -9922,7 +9922,7 @@
                 <a:ea typeface="Arial" pitchFamily="34" charset="-122"/>
                 <a:cs typeface="Arial" pitchFamily="34" charset="-120"/>
               </a:rPr>
-              <a:t>An unstable pole means each output sample amplifies the last — growing exponentially until it hits ≈ 10²⁸⁷. Exactly what plot 4 shows.</a:t>
+              <a:t>An unstable pole means each output sample amplifies the last, growing exponentially until it hits ≈ 10²⁸⁷. This is exactly what plot 4 shows.</a:t>
             </a:r>
             <a:endParaRPr lang="en-US" sz="2100" dirty="0"/>
           </a:p>
@@ -9983,7 +9983,7 @@
                 <a:ea typeface="Arial" pitchFamily="34" charset="-122"/>
                 <a:cs typeface="Arial" pitchFamily="34" charset="-120"/>
               </a:rPr>
-              <a:t>This is a genuine numerical-analysis result, not a software fluke — and it is the course's stated goal of investigating good filter choice.</a:t>
+              <a:t>This is a genuine numerical-analysis result, not a software fluke, and it matches the course's stated goal of investigating good filter choice.</a:t>
             </a:r>
             <a:endParaRPr lang="en-US" sz="2250" dirty="0"/>
           </a:p>

</xml_diff>